<commit_message>
Enhance bulleted_boxes_slide functionality by adjusting text wrapping calculations and margins for improved layout. Implement auto-sizing for bullet text when conditions are met. Update test presentation file to reflect changes.
</commit_message>
<xml_diff>
--- a/src/tests/test_bulleted_boxes_slide.pptx
+++ b/src/tests/test_bulleted_boxes_slide.pptx
@@ -3219,7 +3219,7 @@
           </a:fontRef>
         </p:style>
         <p:txBody>
-          <a:bodyPr rtlCol="0" anchor="t" wrap="square" lIns="137160" rIns="137160" tIns="137160"/>
+          <a:bodyPr rtlCol="0" anchor="t" wrap="square" lIns="137160" rIns="137160" tIns="137160" bIns="137160"/>
           <a:lstStyle/>
           <a:p>
             <a:pPr algn="l">
@@ -3380,7 +3380,7 @@
           </a:fontRef>
         </p:style>
         <p:txBody>
-          <a:bodyPr rtlCol="0" anchor="t" wrap="square" lIns="137160" rIns="137160" tIns="137160"/>
+          <a:bodyPr rtlCol="0" anchor="t" wrap="square" lIns="137160" rIns="137160" tIns="137160" bIns="137160"/>
           <a:lstStyle/>
           <a:p>
             <a:pPr algn="l">

</xml_diff>